<commit_message>
Add upcoming GitHub events closing segment
Close the session with remote-accessible, free-to-attend-online events
so attendees leave with a concrete way to keep building:

- GitHub Universe 2026 (Oct 28-29, free virtual pass)
- Microsoft Ignite 2026 (Nov 17-20, free digital pass)
- Microsoft Reactor recurring Copilot classes
- github.com/resources/events

Adds a 0:55-0:58 segment to the run of show, a "Keep building" slide
before the closing slide, matching sections on the Pages site and
learner handout, and a facilitator reminder to re-verify dates before
each delivery.

Co-authored-by: Copilot App <223556219+Copilot@users.noreply.github.com>
Copilot-Session: 2b09f0e9-4e65-420d-aedc-ae816d3a29ae
</commit_message>
<xml_diff>
--- a/outfitter-with-microsoft.pptx
+++ b/outfitter-with-microsoft.pptx
@@ -16,6 +16,7 @@
     <p:sldId id="265" r:id="rId16"/>
     <p:sldId id="266" r:id="rId17"/>
     <p:sldId id="267" r:id="rId18"/>
+    <p:sldId id="269" r:id="rId21"/>
     <p:sldId id="268" r:id="rId19"/>
   </p:sldIdLst>
   <p:sldSz cx="9144000" cy="6858000" type="screen4x3"/>
@@ -277,7 +278,40 @@
           <a:lstStyle/>
           <a:p>
             <a:r>
-              <a:t>Use the remaining time for Q&amp;A. Map answers back to project context, Agent Mode boundaries, evidence, and small-team reuse.</a:t>
+              <a:t>Close the capability loop before Q&amp;A. Everything here is remote-accessible, so nobody needs to travel.</a:t>
+            </a:r>
+          </a:p>
+          <a:p/>
+          <a:p>
+            <a:r>
+              <a:t>GitHub Universe 2026, October 28-29: free virtual pass, sessions on Copilot and agent mode, recordings available on demand.</a:t>
+            </a:r>
+          </a:p>
+          <a:p>
+            <a:r>
+              <a:t>Microsoft Ignite 2026, November 17-20: free digital pass covering Copilot, agents, and the wider Microsoft tooling.</a:t>
+            </a:r>
+          </a:p>
+          <a:p>
+            <a:r>
+              <a:t>Microsoft Reactor: short, free, recurring live classes on Copilot Chat, agent mode, and MCP in VS Code.</a:t>
+            </a:r>
+          </a:p>
+          <a:p>
+            <a:r>
+              <a:t>github.com/resources/events: the full calendar of upcoming webinars and recorded sessions.</a:t>
+            </a:r>
+          </a:p>
+          <a:p/>
+          <a:p>
+            <a:r>
+              <a:t>Say: pick one and pair it with the capability you just wrote down. Register before you leave the room. A session you attend with a specific build in mind is worth far more than one you attend out of general interest.</a:t>
+            </a:r>
+          </a:p>
+          <a:p/>
+          <a:p>
+            <a:r>
+              <a:t>Confirm dates and registration links the week you deliver; schedules change. If a date has passed, point to the on-demand recordings instead.</a:t>
             </a:r>
           </a:p>
         </p:txBody>
@@ -4264,6 +4298,191 @@
                 <a:latin typeface="Aptos"/>
               </a:rPr>
               <a:t>Outfitter with Microsoft • Build the Capability</a:t>
+            </a:r>
+          </a:p>
+        </p:txBody>
+      </p:sp>
+    </p:spTree>
+  </p:cSld>
+  <p:clrMapOvr>
+    <a:masterClrMapping/>
+  </p:clrMapOvr>
+</p:sld>
+</file>
+
+<file path=ppt/slides/slide14.xml><?xml version="1.0" encoding="utf-8"?>
+<p:sld xmlns:a="http://schemas.openxmlformats.org/drawingml/2006/main" xmlns:r="http://schemas.openxmlformats.org/officeDocument/2006/relationships" xmlns:p="http://schemas.openxmlformats.org/presentationml/2006/main">
+  <p:cSld>
+    <p:spTree>
+      <p:nvGrpSpPr>
+        <p:cNvPr id="1" name=""/>
+        <p:cNvGrpSpPr/>
+        <p:nvPr/>
+      </p:nvGrpSpPr>
+      <p:grpSpPr/>
+      <p:sp>
+        <p:nvSpPr>
+          <p:cNvPr id="2" name="Shape 2"/>
+          <p:cNvSpPr/>
+          <p:nvPr/>
+        </p:nvSpPr>
+        <p:spPr>
+          <a:xfrm>
+            <a:off x="500000" y="1200000"/>
+            <a:ext cx="100000" cy="4700000"/>
+          </a:xfrm>
+          <a:prstGeom prst="rect">
+            <a:avLst/>
+          </a:prstGeom>
+          <a:solidFill>
+            <a:srgbClr val="15A3A3"/>
+          </a:solidFill>
+        </p:spPr>
+        <p:txBody>
+          <a:bodyPr rtlCol="0" anchor="ctr"/>
+          <a:lstStyle/>
+          <a:p/>
+        </p:txBody>
+      </p:sp>
+      <p:sp>
+        <p:nvSpPr>
+          <p:cNvPr id="3" name="TextBox 3"/>
+          <p:cNvSpPr txBox="1"/>
+          <p:nvPr/>
+        </p:nvSpPr>
+        <p:spPr>
+          <a:xfrm>
+            <a:off x="700000" y="350000"/>
+            <a:ext cx="7900000" cy="700000"/>
+          </a:xfrm>
+          <a:prstGeom prst="rect">
+            <a:avLst/>
+          </a:prstGeom>
+        </p:spPr>
+        <p:txBody>
+          <a:bodyPr wrap="square" rtlCol="0">
+            <a:spAutoFit/>
+          </a:bodyPr>
+          <a:lstStyle/>
+          <a:p>
+            <a:r>
+              <a:rPr b="1" sz="3000">
+                <a:solidFill>
+                  <a:srgbClr val="0D3B49"/>
+                </a:solidFill>
+                <a:latin typeface="Aptos Display"/>
+              </a:rPr>
+              <a:t>Keep building</a:t>
+            </a:r>
+          </a:p>
+        </p:txBody>
+      </p:sp>
+      <p:sp>
+        <p:nvSpPr>
+          <p:cNvPr id="4" name="TextBox 4"/>
+          <p:cNvSpPr txBox="1"/>
+          <p:nvPr/>
+        </p:nvSpPr>
+        <p:spPr>
+          <a:xfrm>
+            <a:off x="900000" y="2200000"/>
+            <a:ext cx="7400000" cy="2500000"/>
+          </a:xfrm>
+          <a:prstGeom prst="rect">
+            <a:avLst/>
+          </a:prstGeom>
+        </p:spPr>
+        <p:txBody>
+          <a:bodyPr wrap="square" rtlCol="0">
+            <a:spAutoFit/>
+          </a:bodyPr>
+          <a:lstStyle/>
+          <a:p>
+            <a:r>
+              <a:rPr sz="2100">
+                <a:solidFill>
+                  <a:srgbClr val="20343B"/>
+                </a:solidFill>
+                <a:latin typeface="Aptos"/>
+              </a:rPr>
+              <a:t>GitHub Universe 2026  ·  Oct 28–29  ·  free virtual pass</a:t>
+            </a:r>
+          </a:p>
+          <a:p>
+            <a:r>
+              <a:rPr sz="2100">
+                <a:solidFill>
+                  <a:srgbClr val="20343B"/>
+                </a:solidFill>
+                <a:latin typeface="Aptos"/>
+              </a:rPr>
+              <a:t>Microsoft Ignite 2026  ·  Nov 17–20  ·  free digital pass</a:t>
+            </a:r>
+          </a:p>
+          <a:p>
+            <a:r>
+              <a:rPr sz="2100">
+                <a:solidFill>
+                  <a:srgbClr val="20343B"/>
+                </a:solidFill>
+                <a:latin typeface="Aptos"/>
+              </a:rPr>
+              <a:t>Microsoft Reactor  ·  recurring live Copilot classes</a:t>
+            </a:r>
+          </a:p>
+          <a:p>
+            <a:r>
+              <a:rPr sz="2100">
+                <a:solidFill>
+                  <a:srgbClr val="20343B"/>
+                </a:solidFill>
+                <a:latin typeface="Aptos"/>
+              </a:rPr>
+              <a:t>github.com/resources/events  ·  webinars and recordings</a:t>
+            </a:r>
+          </a:p>
+        </p:txBody>
+      </p:sp>
+      <p:sp>
+        <p:nvSpPr>
+          <p:cNvPr id="5" name="TextBox 5"/>
+          <p:cNvSpPr txBox="1"/>
+          <p:nvPr/>
+        </p:nvSpPr>
+        <p:spPr>
+          <a:xfrm>
+            <a:off x="900000" y="5500000"/>
+            <a:ext cx="7400000" cy="700000"/>
+          </a:xfrm>
+          <a:prstGeom prst="rect">
+            <a:avLst/>
+          </a:prstGeom>
+        </p:spPr>
+        <p:txBody>
+          <a:bodyPr wrap="square" rtlCol="0">
+            <a:spAutoFit/>
+          </a:bodyPr>
+          <a:lstStyle/>
+          <a:p>
+            <a:r>
+              <a:rPr b="1" sz="1800">
+                <a:solidFill>
+                  <a:srgbClr val="096B72"/>
+                </a:solidFill>
+                <a:latin typeface="Aptos"/>
+              </a:rPr>
+              <a:t>Every option is remote-accessible and free to attend online.</a:t>
+            </a:r>
+          </a:p>
+          <a:p>
+            <a:r>
+              <a:rPr b="1" sz="1800">
+                <a:solidFill>
+                  <a:srgbClr val="096B72"/>
+                </a:solidFill>
+                <a:latin typeface="Aptos"/>
+              </a:rPr>
+              <a:t>Pair one with the capability you just chose.</a:t>
             </a:r>
           </a:p>
         </p:txBody>

</xml_diff>